<commit_message>
Polish presentation page motion
</commit_message>
<xml_diff>
--- a/dist/presentation/eyepik-interested-buyer-automation.pptx
+++ b/dist/presentation/eyepik-interested-buyer-automation.pptx
@@ -2,18 +2,18 @@
 <file path=ppt/presentation.xml><?xml version="1.0" encoding="utf-8"?>
 <p:presentation xmlns:p="http://schemas.openxmlformats.org/presentationml/2006/main">
   <p:sldMasterIdLst>
-    <p:sldMasterId xmlns:r="http://schemas.openxmlformats.org/officeDocument/2006/relationships" id="2147483648" r:id="R27229ca08c99464c"/>
+    <p:sldMasterId xmlns:r="http://schemas.openxmlformats.org/officeDocument/2006/relationships" id="2147483648" r:id="Rbae8245cf10b40c4"/>
   </p:sldMasterIdLst>
   <p:notesMasterIdLst>
-    <p:notesMasterId xmlns:r="http://schemas.openxmlformats.org/officeDocument/2006/relationships" r:id="R142d6bdaa3e54594"/>
+    <p:notesMasterId xmlns:r="http://schemas.openxmlformats.org/officeDocument/2006/relationships" r:id="R217700cb76664b2e"/>
   </p:notesMasterIdLst>
   <p:sldIdLst>
-    <p:sldId xmlns:r="http://schemas.openxmlformats.org/officeDocument/2006/relationships" id="256" r:id="R7d6738551c9148ed"/>
-    <p:sldId xmlns:r="http://schemas.openxmlformats.org/officeDocument/2006/relationships" id="257" r:id="R8b1aa8c3ed864a33"/>
-    <p:sldId xmlns:r="http://schemas.openxmlformats.org/officeDocument/2006/relationships" id="258" r:id="Rcd75f4398e1c4f69"/>
-    <p:sldId xmlns:r="http://schemas.openxmlformats.org/officeDocument/2006/relationships" id="259" r:id="R42712a4d0deb490e"/>
-    <p:sldId xmlns:r="http://schemas.openxmlformats.org/officeDocument/2006/relationships" id="260" r:id="R5e560572d191402b"/>
-    <p:sldId xmlns:r="http://schemas.openxmlformats.org/officeDocument/2006/relationships" id="261" r:id="R47d75fb3446240a3"/>
+    <p:sldId xmlns:r="http://schemas.openxmlformats.org/officeDocument/2006/relationships" id="256" r:id="R3cae90e6307446ea"/>
+    <p:sldId xmlns:r="http://schemas.openxmlformats.org/officeDocument/2006/relationships" id="257" r:id="R1626d5c2477a4c11"/>
+    <p:sldId xmlns:r="http://schemas.openxmlformats.org/officeDocument/2006/relationships" id="258" r:id="R9430c74ea20c4a1e"/>
+    <p:sldId xmlns:r="http://schemas.openxmlformats.org/officeDocument/2006/relationships" id="259" r:id="Ree2b23e51c9445a5"/>
+    <p:sldId xmlns:r="http://schemas.openxmlformats.org/officeDocument/2006/relationships" id="260" r:id="Raa45c8c518f740b7"/>
+    <p:sldId xmlns:r="http://schemas.openxmlformats.org/officeDocument/2006/relationships" id="261" r:id="R7892554f1ab64f7a"/>
   </p:sldIdLst>
   <p:sldSz cx="12192000" cy="6858000"/>
   <p:notesSz cx="6858000" cy="9144000"/>
@@ -820,7 +820,7 @@
           <p:cNvPr id="3" name="Title">
             <a:extLst xmlns:a="http://schemas.openxmlformats.org/drawingml/2006/main">
               <a:ext uri="{FF2B5EF4-FFF2-40B4-BE49-F238E27FC236}">
-                <a16:creationId xmlns:a16="http://schemas.microsoft.com/office/drawing/2014/main" id="{BA7E0B94-814D-47BB-8C53-260DE3F6EEE5}"/>
+                <a16:creationId xmlns:a16="http://schemas.microsoft.com/office/drawing/2014/main" id="{8E7899E1-E937-4B49-B403-55B4A46494B4}"/>
               </a:ext>
             </a:extLst>
           </p:cNvPr>
@@ -977,7 +977,7 @@
           <p:cNvPr id="2" name="Subtitle">
             <a:extLst xmlns:a="http://schemas.openxmlformats.org/drawingml/2006/main">
               <a:ext uri="{FF2B5EF4-FFF2-40B4-BE49-F238E27FC236}">
-                <a16:creationId xmlns:a16="http://schemas.microsoft.com/office/drawing/2014/main" id="{F6A6BAD9-EA3B-4219-95B2-92BF17DEB8FB}"/>
+                <a16:creationId xmlns:a16="http://schemas.microsoft.com/office/drawing/2014/main" id="{DCF17844-FCDF-484D-B613-3ACEF441203B}"/>
               </a:ext>
             </a:extLst>
           </p:cNvPr>
@@ -1151,7 +1151,7 @@
           <p:cNvPr id="2" name="Section title">
             <a:extLst xmlns:a="http://schemas.openxmlformats.org/drawingml/2006/main">
               <a:ext uri="{FF2B5EF4-FFF2-40B4-BE49-F238E27FC236}">
-                <a16:creationId xmlns:a16="http://schemas.microsoft.com/office/drawing/2014/main" id="{32B1559E-E3BC-4A4F-AD45-9B49FE5A8F8B}"/>
+                <a16:creationId xmlns:a16="http://schemas.microsoft.com/office/drawing/2014/main" id="{8511EF7B-7800-4F73-8D85-690FDF0369FC}"/>
               </a:ext>
             </a:extLst>
           </p:cNvPr>
@@ -1325,7 +1325,7 @@
           <p:cNvPr id="3" name="Title">
             <a:extLst xmlns:a="http://schemas.openxmlformats.org/drawingml/2006/main">
               <a:ext uri="{FF2B5EF4-FFF2-40B4-BE49-F238E27FC236}">
-                <a16:creationId xmlns:a16="http://schemas.microsoft.com/office/drawing/2014/main" id="{FB859D02-3F07-4046-B4F2-C043D075A47D}"/>
+                <a16:creationId xmlns:a16="http://schemas.microsoft.com/office/drawing/2014/main" id="{E762999E-CB21-4CA9-A59C-6F4A130322B8}"/>
               </a:ext>
             </a:extLst>
           </p:cNvPr>
@@ -1482,7 +1482,7 @@
           <p:cNvPr id="2" name="Body">
             <a:extLst xmlns:a="http://schemas.openxmlformats.org/drawingml/2006/main">
               <a:ext uri="{FF2B5EF4-FFF2-40B4-BE49-F238E27FC236}">
-                <a16:creationId xmlns:a16="http://schemas.microsoft.com/office/drawing/2014/main" id="{EC17CD0E-1313-49AC-B79B-E75ADBA792D8}"/>
+                <a16:creationId xmlns:a16="http://schemas.microsoft.com/office/drawing/2014/main" id="{072805DB-43EF-4601-BF9B-7FCC8267593A}"/>
               </a:ext>
             </a:extLst>
           </p:cNvPr>
@@ -1656,7 +1656,7 @@
           <p:cNvPr id="4" name="Title">
             <a:extLst xmlns:a="http://schemas.openxmlformats.org/drawingml/2006/main">
               <a:ext uri="{FF2B5EF4-FFF2-40B4-BE49-F238E27FC236}">
-                <a16:creationId xmlns:a16="http://schemas.microsoft.com/office/drawing/2014/main" id="{6699E77E-BF4B-4711-98DB-2A94A2852481}"/>
+                <a16:creationId xmlns:a16="http://schemas.microsoft.com/office/drawing/2014/main" id="{9F4F6A88-25D2-48D7-8303-4392DCB5B788}"/>
               </a:ext>
             </a:extLst>
           </p:cNvPr>
@@ -1813,7 +1813,7 @@
           <p:cNvPr id="2" name="Left column">
             <a:extLst xmlns:a="http://schemas.openxmlformats.org/drawingml/2006/main">
               <a:ext uri="{FF2B5EF4-FFF2-40B4-BE49-F238E27FC236}">
-                <a16:creationId xmlns:a16="http://schemas.microsoft.com/office/drawing/2014/main" id="{EF7B0D61-7037-4DEE-9649-8917442C63F0}"/>
+                <a16:creationId xmlns:a16="http://schemas.microsoft.com/office/drawing/2014/main" id="{DB15FE04-4C8E-4023-9023-77D93FB90232}"/>
               </a:ext>
             </a:extLst>
           </p:cNvPr>
@@ -1970,7 +1970,7 @@
           <p:cNvPr id="3" name="Right column">
             <a:extLst xmlns:a="http://schemas.openxmlformats.org/drawingml/2006/main">
               <a:ext uri="{FF2B5EF4-FFF2-40B4-BE49-F238E27FC236}">
-                <a16:creationId xmlns:a16="http://schemas.microsoft.com/office/drawing/2014/main" id="{41E11D5D-D1C6-459D-895B-27676087C1D0}"/>
+                <a16:creationId xmlns:a16="http://schemas.microsoft.com/office/drawing/2014/main" id="{8B3F4CED-7125-4DC0-B9AE-52BF29AF8C6D}"/>
               </a:ext>
             </a:extLst>
           </p:cNvPr>
@@ -2144,7 +2144,7 @@
           <p:cNvPr id="3" name="Title">
             <a:extLst xmlns:a="http://schemas.openxmlformats.org/drawingml/2006/main">
               <a:ext uri="{FF2B5EF4-FFF2-40B4-BE49-F238E27FC236}">
-                <a16:creationId xmlns:a16="http://schemas.microsoft.com/office/drawing/2014/main" id="{EE2B7527-F676-4751-8194-F5CF1625ACA0}"/>
+                <a16:creationId xmlns:a16="http://schemas.microsoft.com/office/drawing/2014/main" id="{26AA5D22-597B-4853-87C7-3A8BC7521FF7}"/>
               </a:ext>
             </a:extLst>
           </p:cNvPr>
@@ -2301,7 +2301,7 @@
           <p:cNvPr id="2" name="Left column">
             <a:extLst xmlns:a="http://schemas.openxmlformats.org/drawingml/2006/main">
               <a:ext uri="{FF2B5EF4-FFF2-40B4-BE49-F238E27FC236}">
-                <a16:creationId xmlns:a16="http://schemas.microsoft.com/office/drawing/2014/main" id="{006CCB47-20FE-43B7-8EAA-863DF911B082}"/>
+                <a16:creationId xmlns:a16="http://schemas.microsoft.com/office/drawing/2014/main" id="{4AEA6FFE-C920-46F5-AB72-6887C32B7C02}"/>
               </a:ext>
             </a:extLst>
           </p:cNvPr>
@@ -2496,12 +2496,12 @@
   </p:cSld>
   <p:clrMap bg1="lt1" tx1="dk1" bg2="lt2" tx2="dk2" accent1="accent1" accent2="accent2" accent3="accent3" accent4="accent4" accent5="accent5" accent6="accent6" hlink="hlink" folHlink="folHlink"/>
   <p:sldLayoutIdLst>
-    <p:sldLayoutId xmlns:r="http://schemas.openxmlformats.org/officeDocument/2006/relationships" id="2147483649" r:id="Re7a891a67852440c"/>
-    <p:sldLayoutId xmlns:r="http://schemas.openxmlformats.org/officeDocument/2006/relationships" id="2147483650" r:id="R8de32a9afc0346b3"/>
-    <p:sldLayoutId xmlns:r="http://schemas.openxmlformats.org/officeDocument/2006/relationships" id="2147483651" r:id="R51ebcf0cba244cdb"/>
-    <p:sldLayoutId xmlns:r="http://schemas.openxmlformats.org/officeDocument/2006/relationships" id="2147483652" r:id="Rc2fc48914c8a4629"/>
-    <p:sldLayoutId xmlns:r="http://schemas.openxmlformats.org/officeDocument/2006/relationships" id="2147483653" r:id="R2249cce677764db9"/>
-    <p:sldLayoutId xmlns:r="http://schemas.openxmlformats.org/officeDocument/2006/relationships" id="2147483654" r:id="R89723be7de264edc"/>
+    <p:sldLayoutId xmlns:r="http://schemas.openxmlformats.org/officeDocument/2006/relationships" id="2147483649" r:id="R1df58f9ecbf944f8"/>
+    <p:sldLayoutId xmlns:r="http://schemas.openxmlformats.org/officeDocument/2006/relationships" id="2147483650" r:id="R68685929b7e44e16"/>
+    <p:sldLayoutId xmlns:r="http://schemas.openxmlformats.org/officeDocument/2006/relationships" id="2147483651" r:id="Rbff056a40b384541"/>
+    <p:sldLayoutId xmlns:r="http://schemas.openxmlformats.org/officeDocument/2006/relationships" id="2147483652" r:id="R1e46ec5bdb0d48f1"/>
+    <p:sldLayoutId xmlns:r="http://schemas.openxmlformats.org/officeDocument/2006/relationships" id="2147483653" r:id="R7ea3eaa3cce84f1d"/>
+    <p:sldLayoutId xmlns:r="http://schemas.openxmlformats.org/officeDocument/2006/relationships" id="2147483654" r:id="R042cabbdb0614a69"/>
   </p:sldLayoutIdLst>
   <p:txStyles>
     <p:titleStyle>
@@ -3052,7 +3052,7 @@
           <p:cNvPr id="16" name="">
             <a:extLst xmlns:a="http://schemas.openxmlformats.org/drawingml/2006/main">
               <a:ext uri="{FF2B5EF4-FFF2-40B4-BE49-F238E27FC236}">
-                <a16:creationId xmlns:a16="http://schemas.microsoft.com/office/drawing/2014/main" id="{CB345C0D-44E1-4066-A1AF-992E754B51A3}"/>
+                <a16:creationId xmlns:a16="http://schemas.microsoft.com/office/drawing/2014/main" id="{D5F7A16F-45B1-4E0E-BEE4-05D6A3EE124C}"/>
               </a:ext>
             </a:extLst>
           </p:cNvPr>
@@ -3110,7 +3110,7 @@
           <p:cNvPr id="2" name="">
             <a:extLst xmlns:a="http://schemas.openxmlformats.org/drawingml/2006/main">
               <a:ext uri="{FF2B5EF4-FFF2-40B4-BE49-F238E27FC236}">
-                <a16:creationId xmlns:a16="http://schemas.microsoft.com/office/drawing/2014/main" id="{A4D0FD05-5021-4482-A41E-92DAB845D697}"/>
+                <a16:creationId xmlns:a16="http://schemas.microsoft.com/office/drawing/2014/main" id="{21A9C8FE-63B7-4DAB-8241-46E2438B5262}"/>
               </a:ext>
             </a:extLst>
           </p:cNvPr>
@@ -3168,7 +3168,7 @@
           <p:cNvPr id="3" name="">
             <a:extLst xmlns:a="http://schemas.openxmlformats.org/drawingml/2006/main">
               <a:ext uri="{FF2B5EF4-FFF2-40B4-BE49-F238E27FC236}">
-                <a16:creationId xmlns:a16="http://schemas.microsoft.com/office/drawing/2014/main" id="{AB43D595-4680-48E5-BEBF-150EBBAB8951}"/>
+                <a16:creationId xmlns:a16="http://schemas.microsoft.com/office/drawing/2014/main" id="{3831DD67-A16F-42E5-93C3-96C60FD70971}"/>
               </a:ext>
             </a:extLst>
           </p:cNvPr>
@@ -3226,7 +3226,7 @@
           <p:cNvPr id="4" name="">
             <a:extLst xmlns:a="http://schemas.openxmlformats.org/drawingml/2006/main">
               <a:ext uri="{FF2B5EF4-FFF2-40B4-BE49-F238E27FC236}">
-                <a16:creationId xmlns:a16="http://schemas.microsoft.com/office/drawing/2014/main" id="{FC6D1659-C587-4C48-BE25-57714B4300D3}"/>
+                <a16:creationId xmlns:a16="http://schemas.microsoft.com/office/drawing/2014/main" id="{1F4DC2EC-1D0E-4042-86F2-3770387402A0}"/>
               </a:ext>
             </a:extLst>
           </p:cNvPr>
@@ -3259,7 +3259,7 @@
           <p:cNvPr id="5" name="">
             <a:extLst xmlns:a="http://schemas.openxmlformats.org/drawingml/2006/main">
               <a:ext uri="{FF2B5EF4-FFF2-40B4-BE49-F238E27FC236}">
-                <a16:creationId xmlns:a16="http://schemas.microsoft.com/office/drawing/2014/main" id="{25F5CF49-6FD3-4D3F-AD3F-FBE859F86166}"/>
+                <a16:creationId xmlns:a16="http://schemas.microsoft.com/office/drawing/2014/main" id="{FCD95FD3-31F0-414A-B3C9-03F76542F8E1}"/>
               </a:ext>
             </a:extLst>
           </p:cNvPr>
@@ -3294,7 +3294,7 @@
           <p:cNvPr id="6" name="">
             <a:extLst xmlns:a="http://schemas.openxmlformats.org/drawingml/2006/main">
               <a:ext uri="{FF2B5EF4-FFF2-40B4-BE49-F238E27FC236}">
-                <a16:creationId xmlns:a16="http://schemas.microsoft.com/office/drawing/2014/main" id="{EA9B02E0-DAEB-48A3-B8B7-349A4806289C}"/>
+                <a16:creationId xmlns:a16="http://schemas.microsoft.com/office/drawing/2014/main" id="{5813BF98-5140-4E09-BAEC-37E7645BE3F2}"/>
               </a:ext>
             </a:extLst>
           </p:cNvPr>
@@ -3352,7 +3352,7 @@
           <p:cNvPr id="7" name="">
             <a:extLst xmlns:a="http://schemas.openxmlformats.org/drawingml/2006/main">
               <a:ext uri="{FF2B5EF4-FFF2-40B4-BE49-F238E27FC236}">
-                <a16:creationId xmlns:a16="http://schemas.microsoft.com/office/drawing/2014/main" id="{472335DC-1E3E-4495-B5DF-57E343634E73}"/>
+                <a16:creationId xmlns:a16="http://schemas.microsoft.com/office/drawing/2014/main" id="{E4DFE33E-BC3F-4E51-8C1E-44D37DEA48F2}"/>
               </a:ext>
             </a:extLst>
           </p:cNvPr>
@@ -3387,7 +3387,7 @@
           <p:cNvPr id="8" name="">
             <a:extLst xmlns:a="http://schemas.openxmlformats.org/drawingml/2006/main">
               <a:ext uri="{FF2B5EF4-FFF2-40B4-BE49-F238E27FC236}">
-                <a16:creationId xmlns:a16="http://schemas.microsoft.com/office/drawing/2014/main" id="{A97C9028-27EB-42E8-976C-28E2E05CBE36}"/>
+                <a16:creationId xmlns:a16="http://schemas.microsoft.com/office/drawing/2014/main" id="{7143B0BA-9A36-4B9A-95CB-FDAA34E86C96}"/>
               </a:ext>
             </a:extLst>
           </p:cNvPr>
@@ -3445,7 +3445,7 @@
           <p:cNvPr id="9" name="">
             <a:extLst xmlns:a="http://schemas.openxmlformats.org/drawingml/2006/main">
               <a:ext uri="{FF2B5EF4-FFF2-40B4-BE49-F238E27FC236}">
-                <a16:creationId xmlns:a16="http://schemas.microsoft.com/office/drawing/2014/main" id="{1B7DDBA8-4D92-4774-9D10-FB0BA71DB5D2}"/>
+                <a16:creationId xmlns:a16="http://schemas.microsoft.com/office/drawing/2014/main" id="{1D66C495-381C-43D7-AE16-5A4EA31508EB}"/>
               </a:ext>
             </a:extLst>
           </p:cNvPr>
@@ -3480,7 +3480,7 @@
           <p:cNvPr id="10" name="">
             <a:extLst xmlns:a="http://schemas.openxmlformats.org/drawingml/2006/main">
               <a:ext uri="{FF2B5EF4-FFF2-40B4-BE49-F238E27FC236}">
-                <a16:creationId xmlns:a16="http://schemas.microsoft.com/office/drawing/2014/main" id="{238D3512-64FD-4F86-BB30-44CC4717DE58}"/>
+                <a16:creationId xmlns:a16="http://schemas.microsoft.com/office/drawing/2014/main" id="{D55163D3-EC79-4A3C-94E5-C131C2BCBDA8}"/>
               </a:ext>
             </a:extLst>
           </p:cNvPr>
@@ -3538,7 +3538,7 @@
           <p:cNvPr id="11" name="">
             <a:extLst xmlns:a="http://schemas.openxmlformats.org/drawingml/2006/main">
               <a:ext uri="{FF2B5EF4-FFF2-40B4-BE49-F238E27FC236}">
-                <a16:creationId xmlns:a16="http://schemas.microsoft.com/office/drawing/2014/main" id="{AFEFC3EB-E139-45C3-A2E6-43136AC38347}"/>
+                <a16:creationId xmlns:a16="http://schemas.microsoft.com/office/drawing/2014/main" id="{140788CD-29AF-4B28-B0CD-348E79D5D254}"/>
               </a:ext>
             </a:extLst>
           </p:cNvPr>
@@ -3573,7 +3573,7 @@
           <p:cNvPr id="12" name="">
             <a:extLst xmlns:a="http://schemas.openxmlformats.org/drawingml/2006/main">
               <a:ext uri="{FF2B5EF4-FFF2-40B4-BE49-F238E27FC236}">
-                <a16:creationId xmlns:a16="http://schemas.microsoft.com/office/drawing/2014/main" id="{DA707BC6-EA4C-46AE-980F-53F54A8E3359}"/>
+                <a16:creationId xmlns:a16="http://schemas.microsoft.com/office/drawing/2014/main" id="{53ABCE48-D7B7-4D5F-B63D-8B0400EA356A}"/>
               </a:ext>
             </a:extLst>
           </p:cNvPr>
@@ -3631,7 +3631,7 @@
           <p:cNvPr id="13" name="">
             <a:extLst xmlns:a="http://schemas.openxmlformats.org/drawingml/2006/main">
               <a:ext uri="{FF2B5EF4-FFF2-40B4-BE49-F238E27FC236}">
-                <a16:creationId xmlns:a16="http://schemas.microsoft.com/office/drawing/2014/main" id="{13F0ED78-CD18-444D-85A5-4D3841B85C08}"/>
+                <a16:creationId xmlns:a16="http://schemas.microsoft.com/office/drawing/2014/main" id="{CE16916E-BD28-4D9D-97B9-B920DC1018CB}"/>
               </a:ext>
             </a:extLst>
           </p:cNvPr>
@@ -3666,7 +3666,7 @@
           <p:cNvPr id="14" name="">
             <a:extLst xmlns:a="http://schemas.openxmlformats.org/drawingml/2006/main">
               <a:ext uri="{FF2B5EF4-FFF2-40B4-BE49-F238E27FC236}">
-                <a16:creationId xmlns:a16="http://schemas.microsoft.com/office/drawing/2014/main" id="{312C5DD8-53BF-48FF-9AAD-B7C3FCA05965}"/>
+                <a16:creationId xmlns:a16="http://schemas.microsoft.com/office/drawing/2014/main" id="{1937690E-A2FA-4F24-A1A4-9DE2D7C8DC5E}"/>
               </a:ext>
             </a:extLst>
           </p:cNvPr>
@@ -3724,7 +3724,7 @@
           <p:cNvPr id="15" name="">
             <a:extLst xmlns:a="http://schemas.openxmlformats.org/drawingml/2006/main">
               <a:ext uri="{FF2B5EF4-FFF2-40B4-BE49-F238E27FC236}">
-                <a16:creationId xmlns:a16="http://schemas.microsoft.com/office/drawing/2014/main" id="{F3787BC6-A773-4257-AB6F-984FA9A62441}"/>
+                <a16:creationId xmlns:a16="http://schemas.microsoft.com/office/drawing/2014/main" id="{A9B56F03-E2D1-4E2D-9772-3CBCFDCC2068}"/>
               </a:ext>
             </a:extLst>
           </p:cNvPr>
@@ -3780,7 +3780,7 @@
     </p:spTree>
     <p:extLst>
       <p:ext uri="{BB962C8B-B14F-4D97-AF65-F5344CB8AC3E}">
-        <p14:creationId xmlns:p14="http://schemas.microsoft.com/office/powerpoint/2010/main" val="1510911461"/>
+        <p14:creationId xmlns:p14="http://schemas.microsoft.com/office/powerpoint/2010/main" val="781055138"/>
       </p:ext>
     </p:extLst>
   </p:cSld>
@@ -3811,7 +3811,7 @@
           <p:cNvPr id="23" name="">
             <a:extLst xmlns:a="http://schemas.openxmlformats.org/drawingml/2006/main">
               <a:ext uri="{FF2B5EF4-FFF2-40B4-BE49-F238E27FC236}">
-                <a16:creationId xmlns:a16="http://schemas.microsoft.com/office/drawing/2014/main" id="{89C78F58-B5E7-4BA6-B3FA-501FBA683574}"/>
+                <a16:creationId xmlns:a16="http://schemas.microsoft.com/office/drawing/2014/main" id="{F2B91A29-FB54-4AA5-8A5E-B692072E31FB}"/>
               </a:ext>
             </a:extLst>
           </p:cNvPr>
@@ -3869,7 +3869,7 @@
           <p:cNvPr id="2" name="">
             <a:extLst xmlns:a="http://schemas.openxmlformats.org/drawingml/2006/main">
               <a:ext uri="{FF2B5EF4-FFF2-40B4-BE49-F238E27FC236}">
-                <a16:creationId xmlns:a16="http://schemas.microsoft.com/office/drawing/2014/main" id="{BE59C956-33FF-4703-A019-DFEE2F40A84E}"/>
+                <a16:creationId xmlns:a16="http://schemas.microsoft.com/office/drawing/2014/main" id="{B19E1D86-87DC-4E87-B5CC-167F7264A678}"/>
               </a:ext>
             </a:extLst>
           </p:cNvPr>
@@ -3927,7 +3927,7 @@
           <p:cNvPr id="3" name="">
             <a:extLst xmlns:a="http://schemas.openxmlformats.org/drawingml/2006/main">
               <a:ext uri="{FF2B5EF4-FFF2-40B4-BE49-F238E27FC236}">
-                <a16:creationId xmlns:a16="http://schemas.microsoft.com/office/drawing/2014/main" id="{78C56423-3CFC-45A2-8186-58585C62FA63}"/>
+                <a16:creationId xmlns:a16="http://schemas.microsoft.com/office/drawing/2014/main" id="{E29B07B5-EF0F-4E55-8061-CFABAECB4F78}"/>
               </a:ext>
             </a:extLst>
           </p:cNvPr>
@@ -3985,7 +3985,7 @@
           <p:cNvPr id="4" name="">
             <a:extLst xmlns:a="http://schemas.openxmlformats.org/drawingml/2006/main">
               <a:ext uri="{FF2B5EF4-FFF2-40B4-BE49-F238E27FC236}">
-                <a16:creationId xmlns:a16="http://schemas.microsoft.com/office/drawing/2014/main" id="{20A066CF-487D-4E58-94FD-C20D4D6ED54E}"/>
+                <a16:creationId xmlns:a16="http://schemas.microsoft.com/office/drawing/2014/main" id="{A1103259-FA5A-48C7-BC2A-608D2C99189B}"/>
               </a:ext>
             </a:extLst>
           </p:cNvPr>
@@ -4043,7 +4043,7 @@
           <p:cNvPr id="5" name="">
             <a:extLst xmlns:a="http://schemas.openxmlformats.org/drawingml/2006/main">
               <a:ext uri="{FF2B5EF4-FFF2-40B4-BE49-F238E27FC236}">
-                <a16:creationId xmlns:a16="http://schemas.microsoft.com/office/drawing/2014/main" id="{5215F9FE-0560-4083-9A8D-09ED99B17328}"/>
+                <a16:creationId xmlns:a16="http://schemas.microsoft.com/office/drawing/2014/main" id="{DEB305F2-47C1-473C-AF2A-6161B3C0ABBB}"/>
               </a:ext>
             </a:extLst>
           </p:cNvPr>
@@ -4076,7 +4076,7 @@
           <p:cNvPr id="6" name="">
             <a:extLst xmlns:a="http://schemas.openxmlformats.org/drawingml/2006/main">
               <a:ext uri="{FF2B5EF4-FFF2-40B4-BE49-F238E27FC236}">
-                <a16:creationId xmlns:a16="http://schemas.microsoft.com/office/drawing/2014/main" id="{FACB8A60-9D89-4F8E-99D5-08897874DF3F}"/>
+                <a16:creationId xmlns:a16="http://schemas.microsoft.com/office/drawing/2014/main" id="{01C404BE-B778-4628-AD41-2736BAD89D86}"/>
               </a:ext>
             </a:extLst>
           </p:cNvPr>
@@ -4134,7 +4134,7 @@
           <p:cNvPr id="7" name="">
             <a:extLst xmlns:a="http://schemas.openxmlformats.org/drawingml/2006/main">
               <a:ext uri="{FF2B5EF4-FFF2-40B4-BE49-F238E27FC236}">
-                <a16:creationId xmlns:a16="http://schemas.microsoft.com/office/drawing/2014/main" id="{7CD0F796-DA09-47F0-8FEF-667C60152AD1}"/>
+                <a16:creationId xmlns:a16="http://schemas.microsoft.com/office/drawing/2014/main" id="{EBDDABBA-302A-4BA0-9C40-9A8EA26CF2A9}"/>
               </a:ext>
             </a:extLst>
           </p:cNvPr>
@@ -4167,7 +4167,7 @@
           <p:cNvPr id="8" name="">
             <a:extLst xmlns:a="http://schemas.openxmlformats.org/drawingml/2006/main">
               <a:ext uri="{FF2B5EF4-FFF2-40B4-BE49-F238E27FC236}">
-                <a16:creationId xmlns:a16="http://schemas.microsoft.com/office/drawing/2014/main" id="{EA7AB26F-2A0B-47F4-8F80-7EADF791CD1D}"/>
+                <a16:creationId xmlns:a16="http://schemas.microsoft.com/office/drawing/2014/main" id="{D2D9D1C8-FE06-4E18-BE7E-CC148D47D57B}"/>
               </a:ext>
             </a:extLst>
           </p:cNvPr>
@@ -4225,7 +4225,7 @@
           <p:cNvPr id="9" name="">
             <a:extLst xmlns:a="http://schemas.openxmlformats.org/drawingml/2006/main">
               <a:ext uri="{FF2B5EF4-FFF2-40B4-BE49-F238E27FC236}">
-                <a16:creationId xmlns:a16="http://schemas.microsoft.com/office/drawing/2014/main" id="{F5D41383-5E91-4C3B-9A4C-8353329C0625}"/>
+                <a16:creationId xmlns:a16="http://schemas.microsoft.com/office/drawing/2014/main" id="{387C1BEC-6CC7-490F-96EA-6440F85C18CA}"/>
               </a:ext>
             </a:extLst>
           </p:cNvPr>
@@ -4258,7 +4258,7 @@
           <p:cNvPr id="10" name="">
             <a:extLst xmlns:a="http://schemas.openxmlformats.org/drawingml/2006/main">
               <a:ext uri="{FF2B5EF4-FFF2-40B4-BE49-F238E27FC236}">
-                <a16:creationId xmlns:a16="http://schemas.microsoft.com/office/drawing/2014/main" id="{664FED4D-FC42-41E6-AA54-234C2D56A9DC}"/>
+                <a16:creationId xmlns:a16="http://schemas.microsoft.com/office/drawing/2014/main" id="{D1CD8F8B-CF1E-49CB-B142-2401C14CF5CB}"/>
               </a:ext>
             </a:extLst>
           </p:cNvPr>
@@ -4316,7 +4316,7 @@
           <p:cNvPr id="11" name="">
             <a:extLst xmlns:a="http://schemas.openxmlformats.org/drawingml/2006/main">
               <a:ext uri="{FF2B5EF4-FFF2-40B4-BE49-F238E27FC236}">
-                <a16:creationId xmlns:a16="http://schemas.microsoft.com/office/drawing/2014/main" id="{161AFD84-E9FA-4996-9675-57193DF59E84}"/>
+                <a16:creationId xmlns:a16="http://schemas.microsoft.com/office/drawing/2014/main" id="{6B58B562-4612-475C-AC0C-4B1761C6A655}"/>
               </a:ext>
             </a:extLst>
           </p:cNvPr>
@@ -4349,7 +4349,7 @@
           <p:cNvPr id="12" name="">
             <a:extLst xmlns:a="http://schemas.openxmlformats.org/drawingml/2006/main">
               <a:ext uri="{FF2B5EF4-FFF2-40B4-BE49-F238E27FC236}">
-                <a16:creationId xmlns:a16="http://schemas.microsoft.com/office/drawing/2014/main" id="{0139E640-8D37-46CE-BE4C-58A340A21985}"/>
+                <a16:creationId xmlns:a16="http://schemas.microsoft.com/office/drawing/2014/main" id="{4B645117-89A3-49CA-893A-93CBD5D26CB3}"/>
               </a:ext>
             </a:extLst>
           </p:cNvPr>
@@ -4384,7 +4384,7 @@
           <p:cNvPr id="13" name="">
             <a:extLst xmlns:a="http://schemas.openxmlformats.org/drawingml/2006/main">
               <a:ext uri="{FF2B5EF4-FFF2-40B4-BE49-F238E27FC236}">
-                <a16:creationId xmlns:a16="http://schemas.microsoft.com/office/drawing/2014/main" id="{F696C923-EFC5-4DC7-A7D6-96AC7390C1F9}"/>
+                <a16:creationId xmlns:a16="http://schemas.microsoft.com/office/drawing/2014/main" id="{5B4E4241-CD4E-4CB6-8AE4-F254D7EEEF6D}"/>
               </a:ext>
             </a:extLst>
           </p:cNvPr>
@@ -4442,7 +4442,7 @@
           <p:cNvPr id="14" name="">
             <a:extLst xmlns:a="http://schemas.openxmlformats.org/drawingml/2006/main">
               <a:ext uri="{FF2B5EF4-FFF2-40B4-BE49-F238E27FC236}">
-                <a16:creationId xmlns:a16="http://schemas.microsoft.com/office/drawing/2014/main" id="{1FD6D8DC-9FDD-4B65-82A0-78D0FBCED7A0}"/>
+                <a16:creationId xmlns:a16="http://schemas.microsoft.com/office/drawing/2014/main" id="{777E4CDE-932E-4005-BB10-B9B6F74ABA2F}"/>
               </a:ext>
             </a:extLst>
           </p:cNvPr>
@@ -4477,7 +4477,7 @@
           <p:cNvPr id="15" name="">
             <a:extLst xmlns:a="http://schemas.openxmlformats.org/drawingml/2006/main">
               <a:ext uri="{FF2B5EF4-FFF2-40B4-BE49-F238E27FC236}">
-                <a16:creationId xmlns:a16="http://schemas.microsoft.com/office/drawing/2014/main" id="{F1477FC6-6549-4CE1-9C7D-A0F4DB4D1CAB}"/>
+                <a16:creationId xmlns:a16="http://schemas.microsoft.com/office/drawing/2014/main" id="{57AC6C06-CA51-4CDC-93E4-C88E9FD9E4FC}"/>
               </a:ext>
             </a:extLst>
           </p:cNvPr>
@@ -4535,7 +4535,7 @@
           <p:cNvPr id="16" name="">
             <a:extLst xmlns:a="http://schemas.openxmlformats.org/drawingml/2006/main">
               <a:ext uri="{FF2B5EF4-FFF2-40B4-BE49-F238E27FC236}">
-                <a16:creationId xmlns:a16="http://schemas.microsoft.com/office/drawing/2014/main" id="{22B2FFA5-453E-4669-B1C2-2EDDF97D0C87}"/>
+                <a16:creationId xmlns:a16="http://schemas.microsoft.com/office/drawing/2014/main" id="{DA69589F-2833-49C9-9C8B-0CB20E189EA2}"/>
               </a:ext>
             </a:extLst>
           </p:cNvPr>
@@ -4570,7 +4570,7 @@
           <p:cNvPr id="17" name="">
             <a:extLst xmlns:a="http://schemas.openxmlformats.org/drawingml/2006/main">
               <a:ext uri="{FF2B5EF4-FFF2-40B4-BE49-F238E27FC236}">
-                <a16:creationId xmlns:a16="http://schemas.microsoft.com/office/drawing/2014/main" id="{4D55E0D4-815E-46DE-BBA7-52084AF812E7}"/>
+                <a16:creationId xmlns:a16="http://schemas.microsoft.com/office/drawing/2014/main" id="{954AE51A-1E6E-4A8A-B4FA-552C870BC1AD}"/>
               </a:ext>
             </a:extLst>
           </p:cNvPr>
@@ -4628,7 +4628,7 @@
           <p:cNvPr id="18" name="">
             <a:extLst xmlns:a="http://schemas.openxmlformats.org/drawingml/2006/main">
               <a:ext uri="{FF2B5EF4-FFF2-40B4-BE49-F238E27FC236}">
-                <a16:creationId xmlns:a16="http://schemas.microsoft.com/office/drawing/2014/main" id="{C463A679-7829-441E-8258-DE14BFE2C298}"/>
+                <a16:creationId xmlns:a16="http://schemas.microsoft.com/office/drawing/2014/main" id="{E0F95B75-093D-487C-9F8E-5503F9EECF5A}"/>
               </a:ext>
             </a:extLst>
           </p:cNvPr>
@@ -4663,7 +4663,7 @@
           <p:cNvPr id="19" name="">
             <a:extLst xmlns:a="http://schemas.openxmlformats.org/drawingml/2006/main">
               <a:ext uri="{FF2B5EF4-FFF2-40B4-BE49-F238E27FC236}">
-                <a16:creationId xmlns:a16="http://schemas.microsoft.com/office/drawing/2014/main" id="{C9115135-DBC0-4049-A65B-428F2A678D56}"/>
+                <a16:creationId xmlns:a16="http://schemas.microsoft.com/office/drawing/2014/main" id="{3B81A285-EC6A-429C-A6A6-3AB67523A40A}"/>
               </a:ext>
             </a:extLst>
           </p:cNvPr>
@@ -4721,7 +4721,7 @@
           <p:cNvPr id="20" name="">
             <a:extLst xmlns:a="http://schemas.openxmlformats.org/drawingml/2006/main">
               <a:ext uri="{FF2B5EF4-FFF2-40B4-BE49-F238E27FC236}">
-                <a16:creationId xmlns:a16="http://schemas.microsoft.com/office/drawing/2014/main" id="{C786C70F-F179-4198-8A92-362ECEDAE167}"/>
+                <a16:creationId xmlns:a16="http://schemas.microsoft.com/office/drawing/2014/main" id="{2CF5FD3E-E838-4D94-8772-78E75DFC225E}"/>
               </a:ext>
             </a:extLst>
           </p:cNvPr>
@@ -4779,7 +4779,7 @@
           <p:cNvPr id="21" name="">
             <a:extLst xmlns:a="http://schemas.openxmlformats.org/drawingml/2006/main">
               <a:ext uri="{FF2B5EF4-FFF2-40B4-BE49-F238E27FC236}">
-                <a16:creationId xmlns:a16="http://schemas.microsoft.com/office/drawing/2014/main" id="{859FFDB7-AC83-4A7B-BE20-5998D03DED3D}"/>
+                <a16:creationId xmlns:a16="http://schemas.microsoft.com/office/drawing/2014/main" id="{F19989E3-5C5C-446E-ACAF-385B44974199}"/>
               </a:ext>
             </a:extLst>
           </p:cNvPr>
@@ -4837,7 +4837,7 @@
           <p:cNvPr id="22" name="">
             <a:extLst xmlns:a="http://schemas.openxmlformats.org/drawingml/2006/main">
               <a:ext uri="{FF2B5EF4-FFF2-40B4-BE49-F238E27FC236}">
-                <a16:creationId xmlns:a16="http://schemas.microsoft.com/office/drawing/2014/main" id="{4AEBD68F-9C39-42CF-B5E2-C349923E405D}"/>
+                <a16:creationId xmlns:a16="http://schemas.microsoft.com/office/drawing/2014/main" id="{74CF2FDC-267D-438B-8279-0D65B6DF925C}"/>
               </a:ext>
             </a:extLst>
           </p:cNvPr>
@@ -4893,7 +4893,7 @@
     </p:spTree>
     <p:extLst>
       <p:ext uri="{BB962C8B-B14F-4D97-AF65-F5344CB8AC3E}">
-        <p14:creationId xmlns:p14="http://schemas.microsoft.com/office/powerpoint/2010/main" val="358673644"/>
+        <p14:creationId xmlns:p14="http://schemas.microsoft.com/office/powerpoint/2010/main" val="853244536"/>
       </p:ext>
     </p:extLst>
   </p:cSld>
@@ -4924,7 +4924,7 @@
           <p:cNvPr id="6" name="">
             <a:extLst xmlns:a="http://schemas.openxmlformats.org/drawingml/2006/main">
               <a:ext uri="{FF2B5EF4-FFF2-40B4-BE49-F238E27FC236}">
-                <a16:creationId xmlns:a16="http://schemas.microsoft.com/office/drawing/2014/main" id="{33065348-DA86-4141-8295-78E18CE143C7}"/>
+                <a16:creationId xmlns:a16="http://schemas.microsoft.com/office/drawing/2014/main" id="{00D609E7-2504-4F75-A6A3-5AE28D3D129B}"/>
               </a:ext>
             </a:extLst>
           </p:cNvPr>
@@ -4982,7 +4982,7 @@
           <p:cNvPr id="2" name="">
             <a:extLst xmlns:a="http://schemas.openxmlformats.org/drawingml/2006/main">
               <a:ext uri="{FF2B5EF4-FFF2-40B4-BE49-F238E27FC236}">
-                <a16:creationId xmlns:a16="http://schemas.microsoft.com/office/drawing/2014/main" id="{DFF79422-DE7E-4D88-91C0-F6E949E87BE7}"/>
+                <a16:creationId xmlns:a16="http://schemas.microsoft.com/office/drawing/2014/main" id="{4DF0F518-22E2-4E96-BD53-2937508AAC5A}"/>
               </a:ext>
             </a:extLst>
           </p:cNvPr>
@@ -5040,7 +5040,7 @@
           <p:cNvPr id="3" name="">
             <a:extLst xmlns:a="http://schemas.openxmlformats.org/drawingml/2006/main">
               <a:ext uri="{FF2B5EF4-FFF2-40B4-BE49-F238E27FC236}">
-                <a16:creationId xmlns:a16="http://schemas.microsoft.com/office/drawing/2014/main" id="{BAB64C1B-9363-4B5F-8894-125980E5B839}"/>
+                <a16:creationId xmlns:a16="http://schemas.microsoft.com/office/drawing/2014/main" id="{E61CD63E-4FF5-49E7-A60F-19E7359333AB}"/>
               </a:ext>
             </a:extLst>
           </p:cNvPr>
@@ -5050,7 +5050,7 @@
           <p:nvPr/>
         </p:nvPicPr>
         <p:blipFill>
-          <a:blip xmlns:r="http://schemas.openxmlformats.org/officeDocument/2006/relationships" xmlns:a="http://schemas.openxmlformats.org/drawingml/2006/main" r:embed="R10b42c4dd1f1452a"/>
+          <a:blip xmlns:r="http://schemas.openxmlformats.org/officeDocument/2006/relationships" xmlns:a="http://schemas.openxmlformats.org/drawingml/2006/main" r:embed="R35445b2dc7f946a7"/>
           <a:srcRect xmlns:a="http://schemas.openxmlformats.org/drawingml/2006/main" l="0" t="16687" r="0" b="16687"/>
           <a:stretch xmlns:a="http://schemas.openxmlformats.org/drawingml/2006/main">
             <a:fillRect l="0" t="0" r="0" b="0"/>
@@ -5073,7 +5073,7 @@
           <p:cNvPr id="4" name="">
             <a:extLst xmlns:a="http://schemas.openxmlformats.org/drawingml/2006/main">
               <a:ext uri="{FF2B5EF4-FFF2-40B4-BE49-F238E27FC236}">
-                <a16:creationId xmlns:a16="http://schemas.microsoft.com/office/drawing/2014/main" id="{376D74C5-BD6E-46DC-90BD-ABE4338BE2D4}"/>
+                <a16:creationId xmlns:a16="http://schemas.microsoft.com/office/drawing/2014/main" id="{9C1FA71A-7630-4675-B761-E6870832516E}"/>
               </a:ext>
             </a:extLst>
           </p:cNvPr>
@@ -5131,7 +5131,7 @@
           <p:cNvPr id="5" name="">
             <a:extLst xmlns:a="http://schemas.openxmlformats.org/drawingml/2006/main">
               <a:ext uri="{FF2B5EF4-FFF2-40B4-BE49-F238E27FC236}">
-                <a16:creationId xmlns:a16="http://schemas.microsoft.com/office/drawing/2014/main" id="{32C42843-9500-40A1-A6DB-933211439D90}"/>
+                <a16:creationId xmlns:a16="http://schemas.microsoft.com/office/drawing/2014/main" id="{EC87E38E-6E2E-4002-8931-8E86B4855E26}"/>
               </a:ext>
             </a:extLst>
           </p:cNvPr>
@@ -5187,7 +5187,7 @@
     </p:spTree>
     <p:extLst>
       <p:ext uri="{BB962C8B-B14F-4D97-AF65-F5344CB8AC3E}">
-        <p14:creationId xmlns:p14="http://schemas.microsoft.com/office/powerpoint/2010/main" val="1163240467"/>
+        <p14:creationId xmlns:p14="http://schemas.microsoft.com/office/powerpoint/2010/main" val="1917957339"/>
       </p:ext>
     </p:extLst>
   </p:cSld>
@@ -5218,7 +5218,7 @@
           <p:cNvPr id="5" name="">
             <a:extLst xmlns:a="http://schemas.openxmlformats.org/drawingml/2006/main">
               <a:ext uri="{FF2B5EF4-FFF2-40B4-BE49-F238E27FC236}">
-                <a16:creationId xmlns:a16="http://schemas.microsoft.com/office/drawing/2014/main" id="{8CCB26B4-DA8F-45A5-9C23-5CBBBAD7540D}"/>
+                <a16:creationId xmlns:a16="http://schemas.microsoft.com/office/drawing/2014/main" id="{A98ACCDD-937D-4A32-82DB-C02E88985D84}"/>
               </a:ext>
             </a:extLst>
           </p:cNvPr>
@@ -5276,7 +5276,7 @@
           <p:cNvPr id="2" name="">
             <a:extLst xmlns:a="http://schemas.openxmlformats.org/drawingml/2006/main">
               <a:ext uri="{FF2B5EF4-FFF2-40B4-BE49-F238E27FC236}">
-                <a16:creationId xmlns:a16="http://schemas.microsoft.com/office/drawing/2014/main" id="{80CE73FD-6577-4029-9F44-A4C61B5D2392}"/>
+                <a16:creationId xmlns:a16="http://schemas.microsoft.com/office/drawing/2014/main" id="{2E4EF06E-3BFE-46EB-86DA-EC51B862549E}"/>
               </a:ext>
             </a:extLst>
           </p:cNvPr>
@@ -5334,7 +5334,7 @@
           <p:cNvPr id="3" name="">
             <a:extLst xmlns:a="http://schemas.openxmlformats.org/drawingml/2006/main">
               <a:ext uri="{FF2B5EF4-FFF2-40B4-BE49-F238E27FC236}">
-                <a16:creationId xmlns:a16="http://schemas.microsoft.com/office/drawing/2014/main" id="{CA98C875-8E39-4741-9669-3163AEAB36A3}"/>
+                <a16:creationId xmlns:a16="http://schemas.microsoft.com/office/drawing/2014/main" id="{E55A5841-F24F-49F4-8A46-E19FEB9A3F60}"/>
               </a:ext>
             </a:extLst>
           </p:cNvPr>
@@ -5344,7 +5344,7 @@
           <p:nvPr/>
         </p:nvPicPr>
         <p:blipFill>
-          <a:blip xmlns:r="http://schemas.openxmlformats.org/officeDocument/2006/relationships" xmlns:a="http://schemas.openxmlformats.org/drawingml/2006/main" r:embed="R0d1eb246b38e466b"/>
+          <a:blip xmlns:r="http://schemas.openxmlformats.org/officeDocument/2006/relationships" xmlns:a="http://schemas.openxmlformats.org/drawingml/2006/main" r:embed="Rdf3b742dbc0d4340"/>
           <a:srcRect xmlns:a="http://schemas.openxmlformats.org/drawingml/2006/main" l="0" t="27654" r="0" b="27654"/>
           <a:stretch xmlns:a="http://schemas.openxmlformats.org/drawingml/2006/main">
             <a:fillRect l="0" t="0" r="0" b="0"/>
@@ -5367,7 +5367,7 @@
           <p:cNvPr id="4" name="">
             <a:extLst xmlns:a="http://schemas.openxmlformats.org/drawingml/2006/main">
               <a:ext uri="{FF2B5EF4-FFF2-40B4-BE49-F238E27FC236}">
-                <a16:creationId xmlns:a16="http://schemas.microsoft.com/office/drawing/2014/main" id="{79A3E291-66B4-45BA-B2E0-297BE67D4C72}"/>
+                <a16:creationId xmlns:a16="http://schemas.microsoft.com/office/drawing/2014/main" id="{F48D6045-DBD8-4700-93D1-6AB7F1647C8B}"/>
               </a:ext>
             </a:extLst>
           </p:cNvPr>
@@ -5423,7 +5423,7 @@
     </p:spTree>
     <p:extLst>
       <p:ext uri="{BB962C8B-B14F-4D97-AF65-F5344CB8AC3E}">
-        <p14:creationId xmlns:p14="http://schemas.microsoft.com/office/powerpoint/2010/main" val="905842123"/>
+        <p14:creationId xmlns:p14="http://schemas.microsoft.com/office/powerpoint/2010/main" val="705765588"/>
       </p:ext>
     </p:extLst>
   </p:cSld>
@@ -5454,7 +5454,7 @@
           <p:cNvPr id="16" name="">
             <a:extLst xmlns:a="http://schemas.openxmlformats.org/drawingml/2006/main">
               <a:ext uri="{FF2B5EF4-FFF2-40B4-BE49-F238E27FC236}">
-                <a16:creationId xmlns:a16="http://schemas.microsoft.com/office/drawing/2014/main" id="{6672F22B-3859-4EAA-9CB5-43AD50E402FE}"/>
+                <a16:creationId xmlns:a16="http://schemas.microsoft.com/office/drawing/2014/main" id="{5E186447-F81F-4B40-983E-39F322BDC915}"/>
               </a:ext>
             </a:extLst>
           </p:cNvPr>
@@ -5512,7 +5512,7 @@
           <p:cNvPr id="2" name="">
             <a:extLst xmlns:a="http://schemas.openxmlformats.org/drawingml/2006/main">
               <a:ext uri="{FF2B5EF4-FFF2-40B4-BE49-F238E27FC236}">
-                <a16:creationId xmlns:a16="http://schemas.microsoft.com/office/drawing/2014/main" id="{45B9AF4B-CDC4-456C-ACE0-72768BC15A24}"/>
+                <a16:creationId xmlns:a16="http://schemas.microsoft.com/office/drawing/2014/main" id="{26F373C5-DF5F-42D5-B79A-6ECA2A59764B}"/>
               </a:ext>
             </a:extLst>
           </p:cNvPr>
@@ -5570,7 +5570,7 @@
           <p:cNvPr id="3" name="">
             <a:extLst xmlns:a="http://schemas.openxmlformats.org/drawingml/2006/main">
               <a:ext uri="{FF2B5EF4-FFF2-40B4-BE49-F238E27FC236}">
-                <a16:creationId xmlns:a16="http://schemas.microsoft.com/office/drawing/2014/main" id="{08E13613-DBEE-4F37-A48B-78FA60A38B36}"/>
+                <a16:creationId xmlns:a16="http://schemas.microsoft.com/office/drawing/2014/main" id="{6396E175-AACF-4A86-96FE-09F620FFB529}"/>
               </a:ext>
             </a:extLst>
           </p:cNvPr>
@@ -5605,7 +5605,7 @@
           <p:cNvPr id="4" name="">
             <a:extLst xmlns:a="http://schemas.openxmlformats.org/drawingml/2006/main">
               <a:ext uri="{FF2B5EF4-FFF2-40B4-BE49-F238E27FC236}">
-                <a16:creationId xmlns:a16="http://schemas.microsoft.com/office/drawing/2014/main" id="{60D1354F-8A01-4646-A3EA-DD458A0DBD89}"/>
+                <a16:creationId xmlns:a16="http://schemas.microsoft.com/office/drawing/2014/main" id="{2934FAFA-BD4B-415F-A8D7-5BD820E11DE3}"/>
               </a:ext>
             </a:extLst>
           </p:cNvPr>
@@ -5680,7 +5680,7 @@
           <p:cNvPr id="5" name="">
             <a:extLst xmlns:a="http://schemas.openxmlformats.org/drawingml/2006/main">
               <a:ext uri="{FF2B5EF4-FFF2-40B4-BE49-F238E27FC236}">
-                <a16:creationId xmlns:a16="http://schemas.microsoft.com/office/drawing/2014/main" id="{8154871A-6BA3-4801-B5C8-B5FD5714736C}"/>
+                <a16:creationId xmlns:a16="http://schemas.microsoft.com/office/drawing/2014/main" id="{261F78C6-4CCB-45E5-9619-C000A256FCEF}"/>
               </a:ext>
             </a:extLst>
           </p:cNvPr>
@@ -5715,7 +5715,7 @@
           <p:cNvPr id="6" name="">
             <a:extLst xmlns:a="http://schemas.openxmlformats.org/drawingml/2006/main">
               <a:ext uri="{FF2B5EF4-FFF2-40B4-BE49-F238E27FC236}">
-                <a16:creationId xmlns:a16="http://schemas.microsoft.com/office/drawing/2014/main" id="{CC331E4E-B710-4A3B-8075-7D12DCC967AB}"/>
+                <a16:creationId xmlns:a16="http://schemas.microsoft.com/office/drawing/2014/main" id="{59A81626-B704-4671-BB20-AB7593EA8536}"/>
               </a:ext>
             </a:extLst>
           </p:cNvPr>
@@ -5773,7 +5773,7 @@
           <p:cNvPr id="7" name="">
             <a:extLst xmlns:a="http://schemas.openxmlformats.org/drawingml/2006/main">
               <a:ext uri="{FF2B5EF4-FFF2-40B4-BE49-F238E27FC236}">
-                <a16:creationId xmlns:a16="http://schemas.microsoft.com/office/drawing/2014/main" id="{0BAFC1E6-F5E1-44EB-912F-BD3FA3246BF8}"/>
+                <a16:creationId xmlns:a16="http://schemas.microsoft.com/office/drawing/2014/main" id="{781CA3F0-3A9A-4DE1-8441-3C42EB2A4E71}"/>
               </a:ext>
             </a:extLst>
           </p:cNvPr>
@@ -5808,7 +5808,7 @@
           <p:cNvPr id="8" name="">
             <a:extLst xmlns:a="http://schemas.openxmlformats.org/drawingml/2006/main">
               <a:ext uri="{FF2B5EF4-FFF2-40B4-BE49-F238E27FC236}">
-                <a16:creationId xmlns:a16="http://schemas.microsoft.com/office/drawing/2014/main" id="{36F78A45-85E3-4D73-B3BA-2D8B45BBA9EA}"/>
+                <a16:creationId xmlns:a16="http://schemas.microsoft.com/office/drawing/2014/main" id="{05FFB40E-1663-4848-A9D6-2EF20C937039}"/>
               </a:ext>
             </a:extLst>
           </p:cNvPr>
@@ -5866,7 +5866,7 @@
           <p:cNvPr id="9" name="">
             <a:extLst xmlns:a="http://schemas.openxmlformats.org/drawingml/2006/main">
               <a:ext uri="{FF2B5EF4-FFF2-40B4-BE49-F238E27FC236}">
-                <a16:creationId xmlns:a16="http://schemas.microsoft.com/office/drawing/2014/main" id="{BEB81275-66B0-4602-A7D7-025C1E3F423D}"/>
+                <a16:creationId xmlns:a16="http://schemas.microsoft.com/office/drawing/2014/main" id="{CC58CDD2-1D48-44C1-80DA-9439C799DE4D}"/>
               </a:ext>
             </a:extLst>
           </p:cNvPr>
@@ -5901,7 +5901,7 @@
           <p:cNvPr id="10" name="">
             <a:extLst xmlns:a="http://schemas.openxmlformats.org/drawingml/2006/main">
               <a:ext uri="{FF2B5EF4-FFF2-40B4-BE49-F238E27FC236}">
-                <a16:creationId xmlns:a16="http://schemas.microsoft.com/office/drawing/2014/main" id="{7215C54D-C4AC-47C4-9A72-5CADC3761D8B}"/>
+                <a16:creationId xmlns:a16="http://schemas.microsoft.com/office/drawing/2014/main" id="{E0A3D0F6-8A41-4663-B753-390361AD9286}"/>
               </a:ext>
             </a:extLst>
           </p:cNvPr>
@@ -5959,7 +5959,7 @@
           <p:cNvPr id="11" name="">
             <a:extLst xmlns:a="http://schemas.openxmlformats.org/drawingml/2006/main">
               <a:ext uri="{FF2B5EF4-FFF2-40B4-BE49-F238E27FC236}">
-                <a16:creationId xmlns:a16="http://schemas.microsoft.com/office/drawing/2014/main" id="{1F496703-EB9D-4207-A3CB-C1C68C0CEB1E}"/>
+                <a16:creationId xmlns:a16="http://schemas.microsoft.com/office/drawing/2014/main" id="{97C37053-4C96-4A01-8AC6-54899D30134F}"/>
               </a:ext>
             </a:extLst>
           </p:cNvPr>
@@ -5994,7 +5994,7 @@
           <p:cNvPr id="12" name="">
             <a:extLst xmlns:a="http://schemas.openxmlformats.org/drawingml/2006/main">
               <a:ext uri="{FF2B5EF4-FFF2-40B4-BE49-F238E27FC236}">
-                <a16:creationId xmlns:a16="http://schemas.microsoft.com/office/drawing/2014/main" id="{23CEEC69-A9BD-4497-AF72-64383A152BDC}"/>
+                <a16:creationId xmlns:a16="http://schemas.microsoft.com/office/drawing/2014/main" id="{CA0B1BEC-8C56-4954-806A-23C80CD536C9}"/>
               </a:ext>
             </a:extLst>
           </p:cNvPr>
@@ -6052,7 +6052,7 @@
           <p:cNvPr id="13" name="">
             <a:extLst xmlns:a="http://schemas.openxmlformats.org/drawingml/2006/main">
               <a:ext uri="{FF2B5EF4-FFF2-40B4-BE49-F238E27FC236}">
-                <a16:creationId xmlns:a16="http://schemas.microsoft.com/office/drawing/2014/main" id="{8F7FAD5F-8DFE-4E2B-A7FA-FBCF6146C3FE}"/>
+                <a16:creationId xmlns:a16="http://schemas.microsoft.com/office/drawing/2014/main" id="{933EBFEA-C90D-4772-86D7-E20E37000A2D}"/>
               </a:ext>
             </a:extLst>
           </p:cNvPr>
@@ -6062,7 +6062,7 @@
           <p:nvPr/>
         </p:nvPicPr>
         <p:blipFill>
-          <a:blip xmlns:r="http://schemas.openxmlformats.org/officeDocument/2006/relationships" xmlns:a="http://schemas.openxmlformats.org/drawingml/2006/main" r:embed="Rddf18d4724be452a"/>
+          <a:blip xmlns:r="http://schemas.openxmlformats.org/officeDocument/2006/relationships" xmlns:a="http://schemas.openxmlformats.org/drawingml/2006/main" r:embed="R19706a27d2f84466"/>
           <a:srcRect xmlns:a="http://schemas.openxmlformats.org/drawingml/2006/main" l="16406" t="0" r="16406" b="0"/>
           <a:stretch xmlns:a="http://schemas.openxmlformats.org/drawingml/2006/main">
             <a:fillRect l="0" t="0" r="0" b="0"/>
@@ -6085,7 +6085,7 @@
           <p:cNvPr id="14" name="">
             <a:extLst xmlns:a="http://schemas.openxmlformats.org/drawingml/2006/main">
               <a:ext uri="{FF2B5EF4-FFF2-40B4-BE49-F238E27FC236}">
-                <a16:creationId xmlns:a16="http://schemas.microsoft.com/office/drawing/2014/main" id="{56DE3058-5F83-4FCC-8B16-DAEA93301D32}"/>
+                <a16:creationId xmlns:a16="http://schemas.microsoft.com/office/drawing/2014/main" id="{661281C1-9161-41C5-B35A-CA780442F47A}"/>
               </a:ext>
             </a:extLst>
           </p:cNvPr>
@@ -6143,7 +6143,7 @@
           <p:cNvPr id="15" name="">
             <a:extLst xmlns:a="http://schemas.openxmlformats.org/drawingml/2006/main">
               <a:ext uri="{FF2B5EF4-FFF2-40B4-BE49-F238E27FC236}">
-                <a16:creationId xmlns:a16="http://schemas.microsoft.com/office/drawing/2014/main" id="{C2846C8F-3605-4341-92D8-BB85AAA3A616}"/>
+                <a16:creationId xmlns:a16="http://schemas.microsoft.com/office/drawing/2014/main" id="{FA532224-4CDF-4998-BA86-E6C0B1E970D6}"/>
               </a:ext>
             </a:extLst>
           </p:cNvPr>
@@ -6199,7 +6199,7 @@
     </p:spTree>
     <p:extLst>
       <p:ext uri="{BB962C8B-B14F-4D97-AF65-F5344CB8AC3E}">
-        <p14:creationId xmlns:p14="http://schemas.microsoft.com/office/powerpoint/2010/main" val="1332936319"/>
+        <p14:creationId xmlns:p14="http://schemas.microsoft.com/office/powerpoint/2010/main" val="1014550215"/>
       </p:ext>
     </p:extLst>
   </p:cSld>
@@ -6230,7 +6230,7 @@
           <p:cNvPr id="13" name="">
             <a:extLst xmlns:a="http://schemas.openxmlformats.org/drawingml/2006/main">
               <a:ext uri="{FF2B5EF4-FFF2-40B4-BE49-F238E27FC236}">
-                <a16:creationId xmlns:a16="http://schemas.microsoft.com/office/drawing/2014/main" id="{AC3C92E4-BB8E-4C07-9C4C-229FF1264416}"/>
+                <a16:creationId xmlns:a16="http://schemas.microsoft.com/office/drawing/2014/main" id="{03759609-7E6E-458A-B94A-BE1B0AD637A9}"/>
               </a:ext>
             </a:extLst>
           </p:cNvPr>
@@ -6288,7 +6288,7 @@
           <p:cNvPr id="2" name="">
             <a:extLst xmlns:a="http://schemas.openxmlformats.org/drawingml/2006/main">
               <a:ext uri="{FF2B5EF4-FFF2-40B4-BE49-F238E27FC236}">
-                <a16:creationId xmlns:a16="http://schemas.microsoft.com/office/drawing/2014/main" id="{EC202A0D-BDB1-40FB-88EF-107A1AEA87BF}"/>
+                <a16:creationId xmlns:a16="http://schemas.microsoft.com/office/drawing/2014/main" id="{7ED38EA0-7516-45E4-87A2-D65F2D522147}"/>
               </a:ext>
             </a:extLst>
           </p:cNvPr>
@@ -6346,7 +6346,7 @@
           <p:cNvPr id="3" name="">
             <a:extLst xmlns:a="http://schemas.openxmlformats.org/drawingml/2006/main">
               <a:ext uri="{FF2B5EF4-FFF2-40B4-BE49-F238E27FC236}">
-                <a16:creationId xmlns:a16="http://schemas.microsoft.com/office/drawing/2014/main" id="{3FA5BBE6-891F-442D-BEB1-A9C81B16A1DE}"/>
+                <a16:creationId xmlns:a16="http://schemas.microsoft.com/office/drawing/2014/main" id="{18AC20B7-4BD3-478F-983B-BCBF1499A416}"/>
               </a:ext>
             </a:extLst>
           </p:cNvPr>
@@ -6404,7 +6404,7 @@
           <p:cNvPr id="4" name="">
             <a:extLst xmlns:a="http://schemas.openxmlformats.org/drawingml/2006/main">
               <a:ext uri="{FF2B5EF4-FFF2-40B4-BE49-F238E27FC236}">
-                <a16:creationId xmlns:a16="http://schemas.microsoft.com/office/drawing/2014/main" id="{92AED005-7369-4C71-BDFF-F0F0671E9EF7}"/>
+                <a16:creationId xmlns:a16="http://schemas.microsoft.com/office/drawing/2014/main" id="{F0DE4933-BFBD-4EB6-9417-C43B6A22F642}"/>
               </a:ext>
             </a:extLst>
           </p:cNvPr>
@@ -6462,7 +6462,7 @@
           <p:cNvPr id="5" name="">
             <a:extLst xmlns:a="http://schemas.openxmlformats.org/drawingml/2006/main">
               <a:ext uri="{FF2B5EF4-FFF2-40B4-BE49-F238E27FC236}">
-                <a16:creationId xmlns:a16="http://schemas.microsoft.com/office/drawing/2014/main" id="{956C439D-9B08-48E0-9D05-AD984CABC92A}"/>
+                <a16:creationId xmlns:a16="http://schemas.microsoft.com/office/drawing/2014/main" id="{D939C11E-5167-4435-883F-6618234E141F}"/>
               </a:ext>
             </a:extLst>
           </p:cNvPr>
@@ -6495,7 +6495,7 @@
           <p:cNvPr id="6" name="">
             <a:extLst xmlns:a="http://schemas.openxmlformats.org/drawingml/2006/main">
               <a:ext uri="{FF2B5EF4-FFF2-40B4-BE49-F238E27FC236}">
-                <a16:creationId xmlns:a16="http://schemas.microsoft.com/office/drawing/2014/main" id="{6BAE2B86-F2E7-4AF8-BC36-57D87ADC1BF3}"/>
+                <a16:creationId xmlns:a16="http://schemas.microsoft.com/office/drawing/2014/main" id="{DAD6FB9D-498D-4320-8980-DC50DE772055}"/>
               </a:ext>
             </a:extLst>
           </p:cNvPr>
@@ -6553,7 +6553,7 @@
           <p:cNvPr id="7" name="">
             <a:extLst xmlns:a="http://schemas.openxmlformats.org/drawingml/2006/main">
               <a:ext uri="{FF2B5EF4-FFF2-40B4-BE49-F238E27FC236}">
-                <a16:creationId xmlns:a16="http://schemas.microsoft.com/office/drawing/2014/main" id="{939A9DB8-32D5-43F3-B0AD-130863C783D8}"/>
+                <a16:creationId xmlns:a16="http://schemas.microsoft.com/office/drawing/2014/main" id="{699EC3CF-0C5C-493D-AE45-ED8D050AA74A}"/>
               </a:ext>
             </a:extLst>
           </p:cNvPr>
@@ -6611,7 +6611,7 @@
           <p:cNvPr id="8" name="">
             <a:extLst xmlns:a="http://schemas.openxmlformats.org/drawingml/2006/main">
               <a:ext uri="{FF2B5EF4-FFF2-40B4-BE49-F238E27FC236}">
-                <a16:creationId xmlns:a16="http://schemas.microsoft.com/office/drawing/2014/main" id="{465EF11D-59A9-4BC0-B4A3-E1EA722E2F2E}"/>
+                <a16:creationId xmlns:a16="http://schemas.microsoft.com/office/drawing/2014/main" id="{AACC528B-89FA-4890-A8E6-1E652F7E606B}"/>
               </a:ext>
             </a:extLst>
           </p:cNvPr>
@@ -6644,7 +6644,7 @@
           <p:cNvPr id="9" name="">
             <a:extLst xmlns:a="http://schemas.openxmlformats.org/drawingml/2006/main">
               <a:ext uri="{FF2B5EF4-FFF2-40B4-BE49-F238E27FC236}">
-                <a16:creationId xmlns:a16="http://schemas.microsoft.com/office/drawing/2014/main" id="{E8D027DF-766C-42DC-A37C-0377BAF5F15A}"/>
+                <a16:creationId xmlns:a16="http://schemas.microsoft.com/office/drawing/2014/main" id="{950DEDF3-33F7-4CD8-80B3-1A28A21E6568}"/>
               </a:ext>
             </a:extLst>
           </p:cNvPr>
@@ -6702,7 +6702,7 @@
           <p:cNvPr id="10" name="">
             <a:extLst xmlns:a="http://schemas.openxmlformats.org/drawingml/2006/main">
               <a:ext uri="{FF2B5EF4-FFF2-40B4-BE49-F238E27FC236}">
-                <a16:creationId xmlns:a16="http://schemas.microsoft.com/office/drawing/2014/main" id="{9C391957-52D4-4C86-B17B-4F41223F4167}"/>
+                <a16:creationId xmlns:a16="http://schemas.microsoft.com/office/drawing/2014/main" id="{1B628BC5-FDBF-4BE8-ABE6-2F00EA00E187}"/>
               </a:ext>
             </a:extLst>
           </p:cNvPr>
@@ -6760,7 +6760,7 @@
           <p:cNvPr id="11" name="">
             <a:extLst xmlns:a="http://schemas.openxmlformats.org/drawingml/2006/main">
               <a:ext uri="{FF2B5EF4-FFF2-40B4-BE49-F238E27FC236}">
-                <a16:creationId xmlns:a16="http://schemas.microsoft.com/office/drawing/2014/main" id="{7999FE6C-4A57-47DC-AA65-11EBC8133374}"/>
+                <a16:creationId xmlns:a16="http://schemas.microsoft.com/office/drawing/2014/main" id="{9F155A45-A105-4EE5-BA56-86857A8662CF}"/>
               </a:ext>
             </a:extLst>
           </p:cNvPr>
@@ -6793,7 +6793,7 @@
           <p:cNvPr id="12" name="">
             <a:extLst xmlns:a="http://schemas.openxmlformats.org/drawingml/2006/main">
               <a:ext uri="{FF2B5EF4-FFF2-40B4-BE49-F238E27FC236}">
-                <a16:creationId xmlns:a16="http://schemas.microsoft.com/office/drawing/2014/main" id="{52FD7118-8735-4DB0-926C-5C116EDB736D}"/>
+                <a16:creationId xmlns:a16="http://schemas.microsoft.com/office/drawing/2014/main" id="{97F83EEA-9F42-4D3D-9D5C-92F556A40998}"/>
               </a:ext>
             </a:extLst>
           </p:cNvPr>
@@ -6849,7 +6849,7 @@
     </p:spTree>
     <p:extLst>
       <p:ext uri="{BB962C8B-B14F-4D97-AF65-F5344CB8AC3E}">
-        <p14:creationId xmlns:p14="http://schemas.microsoft.com/office/powerpoint/2010/main" val="1044482953"/>
+        <p14:creationId xmlns:p14="http://schemas.microsoft.com/office/powerpoint/2010/main" val="1573072278"/>
       </p:ext>
     </p:extLst>
   </p:cSld>

</xml_diff>